<commit_message>
Add new disposable markdown files for Alex and CCT workflows
- Introduced `_DISPOSABLE_Alex_hero_population_thread.md` and its PDF version to document the population lock and plot provenance for HERO and F-HERO analyses.
- Created `_DISPOSABLE_CCT_P2b_workflow_thread.md` to outline the current status and tasks for the CCT P2b workflow, ensuring clarity on ongoing actions and responsibilities.
- Updated `statistics.json` to reflect the latest user and agent message counts, maintaining accurate project activity tracking.

These additions enhance the documentation and workflow management for ongoing analyses, supporting effective collaboration and decision-making.
</commit_message>
<xml_diff>
--- a/3-Master_Plan/re_entry/HEROs_and_PASSes/slides/OLD_vs_NEW_data_intervals.pptx
+++ b/3-Master_Plan/re_entry/HEROs_and_PASSes/slides/OLD_vs_NEW_data_intervals.pptx
@@ -119,6 +119,11 @@
       </a:defRPr>
     </a:lvl9pPr>
   </p:defaultTextStyle>
+  <p:extLst>
+    <p:ext uri="{EFAFB233-063F-42B5-8137-9DF3F51BA10A}">
+      <p15:sldGuideLst xmlns:p15="http://schemas.microsoft.com/office/powerpoint/2012/main"/>
+    </p:ext>
+  </p:extLst>
 </p:presentation>
 </file>
 
@@ -204,7 +209,7 @@
           <a:p>
             <a:fld id="{4128BE16-E189-B440-9E39-16C064312CAC}" type="datetimeFigureOut">
               <a:rPr lang="en-US" smtClean="0"/>
-              <a:t>8/20/26</a:t>
+              <a:t>8/25/26</a:t>
             </a:fld>
             <a:endParaRPr lang="en-US"/>
           </a:p>
@@ -618,7 +623,7 @@
           <a:p>
             <a:fld id="{CC5CC62E-6DFB-3B47-8770-DE5A9D482877}" type="datetime1">
               <a:rPr lang="en-US" smtClean="0"/>
-              <a:t>8/20/26</a:t>
+              <a:t>8/25/26</a:t>
             </a:fld>
             <a:endParaRPr lang="en-US"/>
           </a:p>
@@ -816,7 +821,7 @@
           <a:p>
             <a:fld id="{685C3867-B8E1-5346-9552-E5F16E1245BA}" type="datetime1">
               <a:rPr lang="en-US" smtClean="0"/>
-              <a:t>8/20/26</a:t>
+              <a:t>8/25/26</a:t>
             </a:fld>
             <a:endParaRPr lang="en-US"/>
           </a:p>
@@ -1024,7 +1029,7 @@
           <a:p>
             <a:fld id="{6B3D42FD-90EA-C44F-9F73-8988A9E55149}" type="datetime1">
               <a:rPr lang="en-US" smtClean="0"/>
-              <a:t>8/20/26</a:t>
+              <a:t>8/25/26</a:t>
             </a:fld>
             <a:endParaRPr lang="en-US"/>
           </a:p>
@@ -1222,7 +1227,7 @@
           <a:p>
             <a:fld id="{DFEE14B6-FE25-F840-A9EF-4568E9E7089C}" type="datetime1">
               <a:rPr lang="en-US" smtClean="0"/>
-              <a:t>8/20/26</a:t>
+              <a:t>8/25/26</a:t>
             </a:fld>
             <a:endParaRPr lang="en-US"/>
           </a:p>
@@ -1497,7 +1502,7 @@
           <a:p>
             <a:fld id="{09BF59BF-C37F-8345-AB62-EFDAFD8181E6}" type="datetime1">
               <a:rPr lang="en-US" smtClean="0"/>
-              <a:t>8/20/26</a:t>
+              <a:t>8/25/26</a:t>
             </a:fld>
             <a:endParaRPr lang="en-US"/>
           </a:p>
@@ -1762,7 +1767,7 @@
           <a:p>
             <a:fld id="{70943CAB-43C8-CE4E-95F3-26C5A31787DC}" type="datetime1">
               <a:rPr lang="en-US" smtClean="0"/>
-              <a:t>8/20/26</a:t>
+              <a:t>8/25/26</a:t>
             </a:fld>
             <a:endParaRPr lang="en-US"/>
           </a:p>
@@ -2174,7 +2179,7 @@
           <a:p>
             <a:fld id="{1642126C-BAEA-4A4B-A40B-92B07F93B3FD}" type="datetime1">
               <a:rPr lang="en-US" smtClean="0"/>
-              <a:t>8/20/26</a:t>
+              <a:t>8/25/26</a:t>
             </a:fld>
             <a:endParaRPr lang="en-US"/>
           </a:p>
@@ -2315,7 +2320,7 @@
           <a:p>
             <a:fld id="{AE78D886-A9EC-0547-8E67-CCA7482A9B9D}" type="datetime1">
               <a:rPr lang="en-US" smtClean="0"/>
-              <a:t>8/20/26</a:t>
+              <a:t>8/25/26</a:t>
             </a:fld>
             <a:endParaRPr lang="en-US"/>
           </a:p>
@@ -2428,7 +2433,7 @@
           <a:p>
             <a:fld id="{ACB61759-6D54-C443-889F-C5B0985B7343}" type="datetime1">
               <a:rPr lang="en-US" smtClean="0"/>
-              <a:t>8/20/26</a:t>
+              <a:t>8/25/26</a:t>
             </a:fld>
             <a:endParaRPr lang="en-US"/>
           </a:p>
@@ -2739,7 +2744,7 @@
           <a:p>
             <a:fld id="{3FCCB9A9-EFBC-714E-A1BB-BB2D3D6387F1}" type="datetime1">
               <a:rPr lang="en-US" smtClean="0"/>
-              <a:t>8/20/26</a:t>
+              <a:t>8/25/26</a:t>
             </a:fld>
             <a:endParaRPr lang="en-US"/>
           </a:p>
@@ -3027,7 +3032,7 @@
           <a:p>
             <a:fld id="{D9547C60-F3A8-8545-BC53-4A4F1DA857EA}" type="datetime1">
               <a:rPr lang="en-US" smtClean="0"/>
-              <a:t>8/20/26</a:t>
+              <a:t>8/25/26</a:t>
             </a:fld>
             <a:endParaRPr lang="en-US"/>
           </a:p>
@@ -3268,7 +3273,7 @@
           <a:p>
             <a:fld id="{1C12A16A-068D-C749-91F2-5320144FB665}" type="datetime1">
               <a:rPr lang="en-US" smtClean="0"/>
-              <a:t>8/20/26</a:t>
+              <a:t>8/25/26</a:t>
             </a:fld>
             <a:endParaRPr lang="en-US"/>
           </a:p>
@@ -3720,14 +3725,14 @@
                 <a:latin typeface="Futura Medium" panose="020B0602020204020303" pitchFamily="34" charset="-79"/>
                 <a:cs typeface="Futura Medium" panose="020B0602020204020303" pitchFamily="34" charset="-79"/>
               </a:rPr>
-              <a:t>OLD vs NEW </a:t>
-            </a:r>
-            <a:r>
-              <a:rPr lang="en-US" sz="5400" i="1" dirty="0" err="1">
+              <a:t>OLD vs </a:t>
+            </a:r>
+            <a:r>
+              <a:rPr lang="en-US" sz="5400" i="1">
                 <a:latin typeface="Futura Medium" panose="020B0602020204020303" pitchFamily="34" charset="-79"/>
                 <a:cs typeface="Futura Medium" panose="020B0602020204020303" pitchFamily="34" charset="-79"/>
               </a:rPr>
-              <a:t>emprical</a:t>
+              <a:t>NEW empirical</a:t>
             </a:r>
             <a:endParaRPr lang="en-US" sz="5400" i="1" dirty="0">
               <a:latin typeface="Futura Medium" panose="020B0602020204020303" pitchFamily="34" charset="-79"/>

</xml_diff>